<commit_message>
Final - After recording
</commit_message>
<xml_diff>
--- a/Presentation.pptx
+++ b/Presentation.pptx
@@ -29,6 +29,7 @@
     <p:sldId id="277" r:id="rId23"/>
     <p:sldId id="278" r:id="rId24"/>
     <p:sldId id="279" r:id="rId25"/>
+    <p:sldId id="280" r:id="rId26"/>
   </p:sldIdLst>
   <p:sldSz cx="9144000" cy="5143500" type="screen16x9"/>
   <p:notesSz cx="6858000" cy="9144000"/>
@@ -4016,13 +4017,6 @@
             <a:r>
               <a:rPr b="1"/>
               <a:t>Indice</a:t>
-            </a:r>
-          </a:p>
-          <a:p>
-            <a:pPr lvl="0"/>
-            <a:r>
-              <a:rPr/>
-              <a:t>Introducción</a:t>
             </a:r>
           </a:p>
           <a:p>
@@ -4780,12 +4774,12 @@
                 <a:latin typeface="Courier"/>
               </a:rPr>
               <a:t>##   simulación beneficios
-## 1          1    -161.98
-## 2          2    -162.87
-## 3          3    -167.51
-## 4          4    -124.42
-## 5          5    -167.06
-## 6          6    -160.98</a:t>
+## 1          1    -162.15
+## 2          2    -162.24
+## 3          3    -125.17
+## 4          4    -159.97
+## 5          5    -156.72
+## 6          6    -147.89</a:t>
             </a:r>
           </a:p>
           <a:p>
@@ -4846,7 +4840,126 @@
               <a:rPr>
                 <a:latin typeface="Courier"/>
               </a:rPr>
-              <a:t>## [1] -11491.37</a:t>
+              <a:t>## [1] -9283.18</a:t>
+            </a:r>
+          </a:p>
+        </p:txBody>
+      </p:sp>
+    </p:spTree>
+  </p:cSld>
+</p:sld>
+</file>
+
+<file path=ppt/slides/slide25.xml><?xml version="1.0" encoding="utf-8"?>
+<p:sld xmlns:a="http://schemas.openxmlformats.org/drawingml/2006/main" xmlns:r="http://schemas.openxmlformats.org/officeDocument/2006/relationships" xmlns:p="http://schemas.openxmlformats.org/presentationml/2006/main">
+  <p:cSld>
+    <p:spTree>
+      <p:nvGrpSpPr>
+        <p:cNvPr id="1" name=""/>
+        <p:cNvGrpSpPr/>
+        <p:nvPr/>
+      </p:nvGrpSpPr>
+      <p:grpSpPr>
+        <a:xfrm>
+          <a:off x="0" y="0"/>
+          <a:ext cx="0" cy="0"/>
+          <a:chOff x="0" y="0"/>
+          <a:chExt cx="0" cy="0"/>
+        </a:xfrm>
+      </p:grpSpPr>
+      <p:sp>
+        <p:nvSpPr>
+          <p:cNvPr id="2" name="Title 1"/>
+          <p:cNvSpPr>
+            <a:spLocks noGrp="1"/>
+          </p:cNvSpPr>
+          <p:nvPr>
+            <p:ph type="title"/>
+          </p:nvPr>
+        </p:nvSpPr>
+        <p:spPr/>
+        <p:txBody>
+          <a:bodyPr/>
+          <a:lstStyle/>
+          <a:p>
+            <a:pPr lvl="0" indent="0" marL="0">
+              <a:buNone/>
+            </a:pPr>
+            <a:r>
+              <a:rPr/>
+              <a:t>Conclusiones</a:t>
+            </a:r>
+          </a:p>
+        </p:txBody>
+      </p:sp>
+      <p:sp>
+        <p:nvSpPr>
+          <p:cNvPr id="3" name="Content Placeholder 2"/>
+          <p:cNvSpPr>
+            <a:spLocks noGrp="1"/>
+          </p:cNvSpPr>
+          <p:nvPr>
+            <p:ph idx="1"/>
+          </p:nvPr>
+        </p:nvSpPr>
+        <p:spPr/>
+        <p:txBody>
+          <a:bodyPr/>
+          <a:lstStyle/>
+          <a:p>
+            <a:pPr lvl="0"/>
+            <a:r>
+              <a:rPr/>
+              <a:t>Alta liquidez global con fuerte concentración de valor</a:t>
+            </a:r>
+          </a:p>
+          <a:p>
+            <a:pPr lvl="0"/>
+            <a:r>
+              <a:rPr/>
+              <a:t>Relación negativa precio–liquidez y estructura competitiva</a:t>
+            </a:r>
+          </a:p>
+          <a:p>
+            <a:pPr lvl="0"/>
+            <a:r>
+              <a:rPr/>
+              <a:t>Coexistencia de items muy activos y una pequeña masa inactiva</a:t>
+            </a:r>
+          </a:p>
+          <a:p>
+            <a:pPr lvl="0"/>
+            <a:r>
+              <a:rPr/>
+              <a:t>Distorsión del mercado por bots y nuevo contenido</a:t>
+            </a:r>
+          </a:p>
+          <a:p>
+            <a:pPr lvl="0"/>
+            <a:r>
+              <a:rPr/>
+              <a:t>Dominio de inversores automatizados y apuestas en cajas</a:t>
+            </a:r>
+          </a:p>
+          <a:p>
+            <a:pPr lvl="0"/>
+            <a:r>
+              <a:rPr/>
+              <a:t>Riesgos éticos por exposición de menores a dinámicas de apuesta</a:t>
+            </a:r>
+          </a:p>
+          <a:p>
+            <a:pPr lvl="0"/>
+            <a:r>
+              <a:rPr/>
+              <a:t>El conflicto principal es entre usuarios, no contra la plataforma</a:t>
+            </a:r>
+          </a:p>
+          <a:p>
+            <a:pPr lvl="0"/>
+            <a:r>
+              <a:rPr/>
+              <a:t>Mercado emergente comparable a dinámicas financieras reales</a:t>
             </a:r>
           </a:p>
         </p:txBody>
@@ -4970,7 +5083,7 @@
             </a:pPr>
             <a:r>
               <a:rPr/>
-              <a:t>Evolución del precio menusal del mercado</a:t>
+              <a:t>Evolución del precio mensual del mercado</a:t>
             </a:r>
           </a:p>
         </p:txBody>

</xml_diff>